<commit_message>
Update workshop lecture slides
</commit_message>
<xml_diff>
--- a/lecture_slides/00_workshop_introduction.pptx
+++ b/lecture_slides/00_workshop_introduction.pptx
@@ -221,7 +221,7 @@
           <a:p>
             <a:fld id="{30E08F2E-5F06-4CE2-A139-452A1382A6F0}" type="datetimeFigureOut">
               <a:rPr lang="en-US"/>
-              <a:t>2/5/26</a:t>
+              <a:t>2/10/26</a:t>
             </a:fld>
             <a:endParaRPr/>
           </a:p>
@@ -386,7 +386,7 @@
           <a:p>
             <a:fld id="{1A4C5DC6-1594-414D-9341-ABA08739246C}" type="datetimeFigureOut">
               <a:rPr lang="en-US"/>
-              <a:t>2/5/26</a:t>
+              <a:t>2/10/26</a:t>
             </a:fld>
             <a:endParaRPr/>
           </a:p>
@@ -4013,13 +4013,13 @@
         </p:spPr>
         <p:txBody>
           <a:bodyPr>
-            <a:normAutofit fontScale="90000"/>
+            <a:normAutofit/>
           </a:bodyPr>
           <a:lstStyle/>
           <a:p>
             <a:r>
               <a:rPr lang="en-US" dirty="0"/>
-              <a:t>Welcome to the Workshop on  Genomic Foundation Models</a:t>
+              <a:t>Welcome to the GFM Workshop</a:t>
             </a:r>
           </a:p>
         </p:txBody>
@@ -6950,7 +6950,7 @@
             <a:pPr algn="ctr"/>
             <a:r>
               <a:rPr lang="en-SA" sz="4800" dirty="0"/>
-              <a:t>Any Question on the organization of workshop</a:t>
+              <a:t>Any Questions?</a:t>
             </a:r>
           </a:p>
         </p:txBody>
@@ -7764,6 +7764,15 @@
 </file>
 
 <file path=customXml/item1.xml><?xml version="1.0" encoding="utf-8"?>
+<?mso-contentType ?>
+<FormTemplates xmlns="http://schemas.microsoft.com/sharepoint/v3/contenttype/forms">
+  <Display>DocumentLibraryForm</Display>
+  <Edit>DocumentLibraryForm</Edit>
+  <New>DocumentLibraryForm</New>
+</FormTemplates>
+</file>
+
+<file path=customXml/item2.xml><?xml version="1.0" encoding="utf-8"?>
 <p:properties xmlns:p="http://schemas.microsoft.com/office/2006/metadata/properties" xmlns:xsi="http://www.w3.org/2001/XMLSchema-instance" xmlns:pc="http://schemas.microsoft.com/office/infopath/2007/PartnerControls">
   <documentManagement>
     <_ip_UnifiedCompliancePolicyUIAction xmlns="http://schemas.microsoft.com/sharepoint/v3" xsi:nil="true"/>
@@ -7781,15 +7790,6 @@
     <MediaServiceKeyPoints xmlns="71af3243-3dd4-4a8d-8c0d-dd76da1f02a5" xsi:nil="true"/>
   </documentManagement>
 </p:properties>
-</file>
-
-<file path=customXml/item2.xml><?xml version="1.0" encoding="utf-8"?>
-<?mso-contentType ?>
-<FormTemplates xmlns="http://schemas.microsoft.com/sharepoint/v3/contenttype/forms">
-  <Display>DocumentLibraryForm</Display>
-  <Edit>DocumentLibraryForm</Edit>
-  <New>DocumentLibraryForm</New>
-</FormTemplates>
 </file>
 
 <file path=customXml/item3.xml><?xml version="1.0" encoding="utf-8"?>
@@ -8099,6 +8099,14 @@
 </file>
 
 <file path=customXml/itemProps1.xml><?xml version="1.0" encoding="utf-8"?>
+<ds:datastoreItem xmlns:ds="http://schemas.openxmlformats.org/officeDocument/2006/customXml" ds:itemID="{78F2847D-96C7-4634-93AB-D232DDB6E5EB}">
+  <ds:schemaRefs>
+    <ds:schemaRef ds:uri="http://schemas.microsoft.com/sharepoint/v3/contenttype/forms"/>
+  </ds:schemaRefs>
+</ds:datastoreItem>
+</file>
+
+<file path=customXml/itemProps2.xml><?xml version="1.0" encoding="utf-8"?>
 <ds:datastoreItem xmlns:ds="http://schemas.openxmlformats.org/officeDocument/2006/customXml" ds:itemID="{4D18307F-863E-465D-9426-B14DA0CBD25E}">
   <ds:schemaRefs>
     <ds:schemaRef ds:uri="http://schemas.microsoft.com/sharepoint/v3"/>
@@ -8113,14 +8121,6 @@
     <ds:schemaRef ds:uri="http://schemas.openxmlformats.org/package/2006/metadata/core-properties"/>
     <ds:schemaRef ds:uri="71af3243-3dd4-4a8d-8c0d-dd76da1f02a5"/>
     <ds:schemaRef ds:uri="http://purl.org/dc/dcmitype/"/>
-  </ds:schemaRefs>
-</ds:datastoreItem>
-</file>
-
-<file path=customXml/itemProps2.xml><?xml version="1.0" encoding="utf-8"?>
-<ds:datastoreItem xmlns:ds="http://schemas.openxmlformats.org/officeDocument/2006/customXml" ds:itemID="{78F2847D-96C7-4634-93AB-D232DDB6E5EB}">
-  <ds:schemaRefs>
-    <ds:schemaRef ds:uri="http://schemas.microsoft.com/sharepoint/v3/contenttype/forms"/>
   </ds:schemaRefs>
 </ds:datastoreItem>
 </file>

</xml_diff>

<commit_message>
Update workshop introduction slide
</commit_message>
<xml_diff>
--- a/lecture_slides/00_workshop_introduction.pptx
+++ b/lecture_slides/00_workshop_introduction.pptx
@@ -221,7 +221,7 @@
           <a:p>
             <a:fld id="{30E08F2E-5F06-4CE2-A139-452A1382A6F0}" type="datetimeFigureOut">
               <a:rPr lang="en-US"/>
-              <a:t>2/10/26</a:t>
+              <a:t>2/14/26</a:t>
             </a:fld>
             <a:endParaRPr/>
           </a:p>
@@ -386,7 +386,7 @@
           <a:p>
             <a:fld id="{1A4C5DC6-1594-414D-9341-ABA08739246C}" type="datetimeFigureOut">
               <a:rPr lang="en-US"/>
-              <a:t>2/10/26</a:t>
+              <a:t>2/14/26</a:t>
             </a:fld>
             <a:endParaRPr/>
           </a:p>
@@ -723,6 +723,90 @@
     <p:extLst>
       <p:ext uri="{BB962C8B-B14F-4D97-AF65-F5344CB8AC3E}">
         <p14:creationId xmlns:p14="http://schemas.microsoft.com/office/powerpoint/2010/main" val="3300829815"/>
+      </p:ext>
+    </p:extLst>
+  </p:cSld>
+  <p:clrMapOvr>
+    <a:masterClrMapping/>
+  </p:clrMapOvr>
+</p:notes>
+</file>
+
+<file path=ppt/notesSlides/notesSlide2.xml><?xml version="1.0" encoding="utf-8"?>
+<p:notes xmlns:a="http://schemas.openxmlformats.org/drawingml/2006/main" xmlns:r="http://schemas.openxmlformats.org/officeDocument/2006/relationships" xmlns:p="http://schemas.openxmlformats.org/presentationml/2006/main">
+  <p:cSld>
+    <p:spTree>
+      <p:nvGrpSpPr>
+        <p:cNvPr id="1" name=""/>
+        <p:cNvGrpSpPr/>
+        <p:nvPr/>
+      </p:nvGrpSpPr>
+      <p:grpSpPr>
+        <a:xfrm>
+          <a:off x="0" y="0"/>
+          <a:ext cx="0" cy="0"/>
+          <a:chOff x="0" y="0"/>
+          <a:chExt cx="0" cy="0"/>
+        </a:xfrm>
+      </p:grpSpPr>
+      <p:sp>
+        <p:nvSpPr>
+          <p:cNvPr id="2" name="Slide Image Placeholder 1"/>
+          <p:cNvSpPr>
+            <a:spLocks noGrp="1" noRot="1" noChangeAspect="1"/>
+          </p:cNvSpPr>
+          <p:nvPr>
+            <p:ph type="sldImg"/>
+          </p:nvPr>
+        </p:nvSpPr>
+        <p:spPr/>
+      </p:sp>
+      <p:sp>
+        <p:nvSpPr>
+          <p:cNvPr id="3" name="Notes Placeholder 2"/>
+          <p:cNvSpPr>
+            <a:spLocks noGrp="1"/>
+          </p:cNvSpPr>
+          <p:nvPr>
+            <p:ph type="body" idx="1"/>
+          </p:nvPr>
+        </p:nvSpPr>
+        <p:spPr/>
+        <p:txBody>
+          <a:bodyPr/>
+          <a:lstStyle/>
+          <a:p>
+            <a:endParaRPr lang="en-SA" dirty="0"/>
+          </a:p>
+        </p:txBody>
+      </p:sp>
+      <p:sp>
+        <p:nvSpPr>
+          <p:cNvPr id="4" name="Slide Number Placeholder 3"/>
+          <p:cNvSpPr>
+            <a:spLocks noGrp="1"/>
+          </p:cNvSpPr>
+          <p:nvPr>
+            <p:ph type="sldNum" sz="quarter" idx="5"/>
+          </p:nvPr>
+        </p:nvSpPr>
+        <p:spPr/>
+        <p:txBody>
+          <a:bodyPr/>
+          <a:lstStyle/>
+          <a:p>
+            <a:fld id="{77542409-6A04-4DC6-AC3A-D3758287A8F2}" type="slidenum">
+              <a:rPr lang="en-SA" smtClean="0"/>
+              <a:t>4</a:t>
+            </a:fld>
+            <a:endParaRPr lang="en-SA"/>
+          </a:p>
+        </p:txBody>
+      </p:sp>
+    </p:spTree>
+    <p:extLst>
+      <p:ext uri="{BB962C8B-B14F-4D97-AF65-F5344CB8AC3E}">
+        <p14:creationId xmlns:p14="http://schemas.microsoft.com/office/powerpoint/2010/main" val="2846168598"/>
       </p:ext>
     </p:extLst>
   </p:cSld>
@@ -4669,7 +4753,7 @@
             </a:r>
             <a:r>
               <a:rPr lang="en-SA" dirty="0">
-                <a:hlinkClick r:id="rId2"/>
+                <a:hlinkClick r:id="rId3"/>
               </a:rPr>
               <a:t>setup page</a:t>
             </a:r>
@@ -4699,6 +4783,59 @@
               <a:rPr lang="en-SA" dirty="0"/>
               <a:t>Running Jupyter server</a:t>
             </a:r>
+          </a:p>
+          <a:p>
+            <a:pPr lvl="1"/>
+            <a:endParaRPr lang="en-SA" dirty="0"/>
+          </a:p>
+          <a:p>
+            <a:r>
+              <a:rPr lang="en-SA" dirty="0">
+                <a:solidFill>
+                  <a:schemeClr val="accent1">
+                    <a:lumMod val="50000"/>
+                  </a:schemeClr>
+                </a:solidFill>
+              </a:rPr>
+              <a:t>The course contains scientific material from a mix of machine learning, </a:t>
+            </a:r>
+            <a:r>
+              <a:rPr lang="en-SA">
+                <a:solidFill>
+                  <a:schemeClr val="accent1">
+                    <a:lumMod val="50000"/>
+                  </a:schemeClr>
+                </a:solidFill>
+              </a:rPr>
+              <a:t>biology and technology</a:t>
+            </a:r>
+            <a:endParaRPr lang="en-SA" dirty="0">
+              <a:solidFill>
+                <a:schemeClr val="accent1">
+                  <a:lumMod val="50000"/>
+                </a:schemeClr>
+              </a:solidFill>
+            </a:endParaRPr>
+          </a:p>
+          <a:p>
+            <a:pPr lvl="1"/>
+            <a:r>
+              <a:rPr lang="en-US" sz="2200" dirty="0">
+                <a:solidFill>
+                  <a:schemeClr val="accent1">
+                    <a:lumMod val="50000"/>
+                  </a:schemeClr>
+                </a:solidFill>
+              </a:rPr>
+              <a:t>Errors and omissions excepted </a:t>
+            </a:r>
+            <a:endParaRPr lang="en-SA" sz="2200" dirty="0">
+              <a:solidFill>
+                <a:schemeClr val="accent1">
+                  <a:lumMod val="50000"/>
+                </a:schemeClr>
+              </a:solidFill>
+            </a:endParaRPr>
           </a:p>
           <a:p>
             <a:endParaRPr lang="en-SA" dirty="0"/>
@@ -7764,35 +7901,6 @@
 </file>
 
 <file path=customXml/item1.xml><?xml version="1.0" encoding="utf-8"?>
-<?mso-contentType ?>
-<FormTemplates xmlns="http://schemas.microsoft.com/sharepoint/v3/contenttype/forms">
-  <Display>DocumentLibraryForm</Display>
-  <Edit>DocumentLibraryForm</Edit>
-  <New>DocumentLibraryForm</New>
-</FormTemplates>
-</file>
-
-<file path=customXml/item2.xml><?xml version="1.0" encoding="utf-8"?>
-<p:properties xmlns:p="http://schemas.microsoft.com/office/2006/metadata/properties" xmlns:xsi="http://www.w3.org/2001/XMLSchema-instance" xmlns:pc="http://schemas.microsoft.com/office/infopath/2007/PartnerControls">
-  <documentManagement>
-    <_ip_UnifiedCompliancePolicyUIAction xmlns="http://schemas.microsoft.com/sharepoint/v3" xsi:nil="true"/>
-    <Image xmlns="71af3243-3dd4-4a8d-8c0d-dd76da1f02a5">
-      <Url xsi:nil="true"/>
-      <Description xsi:nil="true"/>
-    </Image>
-    <Status xmlns="71af3243-3dd4-4a8d-8c0d-dd76da1f02a5">Not started</Status>
-    <Background xmlns="71af3243-3dd4-4a8d-8c0d-dd76da1f02a5">false</Background>
-    <_ip_UnifiedCompliancePolicyProperties xmlns="http://schemas.microsoft.com/sharepoint/v3" xsi:nil="true"/>
-    <ImageTagsTaxHTField xmlns="71af3243-3dd4-4a8d-8c0d-dd76da1f02a5">
-      <Terms xmlns="http://schemas.microsoft.com/office/infopath/2007/PartnerControls"/>
-    </ImageTagsTaxHTField>
-    <TaxCatchAll xmlns="230e9df3-be65-4c73-a93b-d1236ebd677e" xsi:nil="true"/>
-    <MediaServiceKeyPoints xmlns="71af3243-3dd4-4a8d-8c0d-dd76da1f02a5" xsi:nil="true"/>
-  </documentManagement>
-</p:properties>
-</file>
-
-<file path=customXml/item3.xml><?xml version="1.0" encoding="utf-8"?>
 <ct:contentTypeSchema xmlns:ct="http://schemas.microsoft.com/office/2006/metadata/contentType" xmlns:ma="http://schemas.microsoft.com/office/2006/metadata/properties/metaAttributes" ct:_="" ma:_="" ma:contentTypeName="Document" ma:contentTypeID="0x01010079F111ED35F8CC479449609E8A0923A6" ma:contentTypeVersion="27" ma:contentTypeDescription="Create a new document." ma:contentTypeScope="" ma:versionID="c6f9a84f66a9c8b9a21755b9ffafb945">
   <xsd:schema xmlns:xsd="http://www.w3.org/2001/XMLSchema" xmlns:xs="http://www.w3.org/2001/XMLSchema" xmlns:p="http://schemas.microsoft.com/office/2006/metadata/properties" xmlns:ns1="http://schemas.microsoft.com/sharepoint/v3" xmlns:ns2="71af3243-3dd4-4a8d-8c0d-dd76da1f02a5" xmlns:ns3="16c05727-aa75-4e4a-9b5f-8a80a1165891" xmlns:ns4="230e9df3-be65-4c73-a93b-d1236ebd677e" targetNamespace="http://schemas.microsoft.com/office/2006/metadata/properties" ma:root="true" ma:fieldsID="27df39e3e7036dff54f89ddd5805ce72" ns1:_="" ns2:_="" ns3:_="" ns4:_="">
     <xsd:import namespace="http://schemas.microsoft.com/sharepoint/v3"/>
@@ -8098,10 +8206,52 @@
 </ct:contentTypeSchema>
 </file>
 
+<file path=customXml/item2.xml><?xml version="1.0" encoding="utf-8"?>
+<p:properties xmlns:p="http://schemas.microsoft.com/office/2006/metadata/properties" xmlns:xsi="http://www.w3.org/2001/XMLSchema-instance" xmlns:pc="http://schemas.microsoft.com/office/infopath/2007/PartnerControls">
+  <documentManagement>
+    <_ip_UnifiedCompliancePolicyUIAction xmlns="http://schemas.microsoft.com/sharepoint/v3" xsi:nil="true"/>
+    <Image xmlns="71af3243-3dd4-4a8d-8c0d-dd76da1f02a5">
+      <Url xsi:nil="true"/>
+      <Description xsi:nil="true"/>
+    </Image>
+    <Status xmlns="71af3243-3dd4-4a8d-8c0d-dd76da1f02a5">Not started</Status>
+    <Background xmlns="71af3243-3dd4-4a8d-8c0d-dd76da1f02a5">false</Background>
+    <_ip_UnifiedCompliancePolicyProperties xmlns="http://schemas.microsoft.com/sharepoint/v3" xsi:nil="true"/>
+    <ImageTagsTaxHTField xmlns="71af3243-3dd4-4a8d-8c0d-dd76da1f02a5">
+      <Terms xmlns="http://schemas.microsoft.com/office/infopath/2007/PartnerControls"/>
+    </ImageTagsTaxHTField>
+    <TaxCatchAll xmlns="230e9df3-be65-4c73-a93b-d1236ebd677e" xsi:nil="true"/>
+    <MediaServiceKeyPoints xmlns="71af3243-3dd4-4a8d-8c0d-dd76da1f02a5" xsi:nil="true"/>
+  </documentManagement>
+</p:properties>
+</file>
+
+<file path=customXml/item3.xml><?xml version="1.0" encoding="utf-8"?>
+<?mso-contentType ?>
+<FormTemplates xmlns="http://schemas.microsoft.com/sharepoint/v3/contenttype/forms">
+  <Display>DocumentLibraryForm</Display>
+  <Edit>DocumentLibraryForm</Edit>
+  <New>DocumentLibraryForm</New>
+</FormTemplates>
+</file>
+
 <file path=customXml/itemProps1.xml><?xml version="1.0" encoding="utf-8"?>
-<ds:datastoreItem xmlns:ds="http://schemas.openxmlformats.org/officeDocument/2006/customXml" ds:itemID="{78F2847D-96C7-4634-93AB-D232DDB6E5EB}">
+<ds:datastoreItem xmlns:ds="http://schemas.openxmlformats.org/officeDocument/2006/customXml" ds:itemID="{074F6EFD-5A76-4C77-A0A3-4BA9EAEE14E7}">
   <ds:schemaRefs>
-    <ds:schemaRef ds:uri="http://schemas.microsoft.com/sharepoint/v3/contenttype/forms"/>
+    <ds:schemaRef ds:uri="http://schemas.microsoft.com/office/2006/metadata/contentType"/>
+    <ds:schemaRef ds:uri="http://schemas.microsoft.com/office/2006/metadata/properties/metaAttributes"/>
+    <ds:schemaRef ds:uri="http://www.w3.org/2001/XMLSchema"/>
+    <ds:schemaRef ds:uri="http://schemas.microsoft.com/office/2006/metadata/properties"/>
+    <ds:schemaRef ds:uri="http://schemas.microsoft.com/sharepoint/v3"/>
+    <ds:schemaRef ds:uri="71af3243-3dd4-4a8d-8c0d-dd76da1f02a5"/>
+    <ds:schemaRef ds:uri="16c05727-aa75-4e4a-9b5f-8a80a1165891"/>
+    <ds:schemaRef ds:uri="230e9df3-be65-4c73-a93b-d1236ebd677e"/>
+    <ds:schemaRef ds:uri="http://schemas.microsoft.com/office/2006/documentManagement/types"/>
+    <ds:schemaRef ds:uri="http://schemas.microsoft.com/office/infopath/2007/PartnerControls"/>
+    <ds:schemaRef ds:uri="http://schemas.openxmlformats.org/package/2006/metadata/core-properties"/>
+    <ds:schemaRef ds:uri="http://purl.org/dc/elements/1.1/"/>
+    <ds:schemaRef ds:uri="http://purl.org/dc/terms/"/>
+    <ds:schemaRef ds:uri="http://schemas.microsoft.com/internal/obd"/>
   </ds:schemaRefs>
 </ds:datastoreItem>
 </file>
@@ -8126,22 +8276,9 @@
 </file>
 
 <file path=customXml/itemProps3.xml><?xml version="1.0" encoding="utf-8"?>
-<ds:datastoreItem xmlns:ds="http://schemas.openxmlformats.org/officeDocument/2006/customXml" ds:itemID="{074F6EFD-5A76-4C77-A0A3-4BA9EAEE14E7}">
+<ds:datastoreItem xmlns:ds="http://schemas.openxmlformats.org/officeDocument/2006/customXml" ds:itemID="{78F2847D-96C7-4634-93AB-D232DDB6E5EB}">
   <ds:schemaRefs>
-    <ds:schemaRef ds:uri="http://schemas.microsoft.com/office/2006/metadata/contentType"/>
-    <ds:schemaRef ds:uri="http://schemas.microsoft.com/office/2006/metadata/properties/metaAttributes"/>
-    <ds:schemaRef ds:uri="http://www.w3.org/2001/XMLSchema"/>
-    <ds:schemaRef ds:uri="http://schemas.microsoft.com/office/2006/metadata/properties"/>
-    <ds:schemaRef ds:uri="http://schemas.microsoft.com/sharepoint/v3"/>
-    <ds:schemaRef ds:uri="71af3243-3dd4-4a8d-8c0d-dd76da1f02a5"/>
-    <ds:schemaRef ds:uri="16c05727-aa75-4e4a-9b5f-8a80a1165891"/>
-    <ds:schemaRef ds:uri="230e9df3-be65-4c73-a93b-d1236ebd677e"/>
-    <ds:schemaRef ds:uri="http://schemas.microsoft.com/office/2006/documentManagement/types"/>
-    <ds:schemaRef ds:uri="http://schemas.microsoft.com/office/infopath/2007/PartnerControls"/>
-    <ds:schemaRef ds:uri="http://schemas.openxmlformats.org/package/2006/metadata/core-properties"/>
-    <ds:schemaRef ds:uri="http://purl.org/dc/elements/1.1/"/>
-    <ds:schemaRef ds:uri="http://purl.org/dc/terms/"/>
-    <ds:schemaRef ds:uri="http://schemas.microsoft.com/internal/obd"/>
+    <ds:schemaRef ds:uri="http://schemas.microsoft.com/sharepoint/v3/contenttype/forms"/>
   </ds:schemaRefs>
 </ds:datastoreItem>
 </file>

</xml_diff>

<commit_message>
Update workshop introduction and Day 1 lecture slides
</commit_message>
<xml_diff>
--- a/lecture_slides/00_workshop_introduction.pptx
+++ b/lecture_slides/00_workshop_introduction.pptx
@@ -4388,7 +4388,7 @@
           <a:p>
             <a:r>
               <a:rPr lang="en-SA" dirty="0"/>
-              <a:t>KAUST Bioinformatics Platform</a:t>
+              <a:t>Member of KAUST Bioinformatics Platform</a:t>
             </a:r>
           </a:p>
           <a:p>
@@ -4435,7 +4435,7 @@
           <a:p>
             <a:pPr lvl="2"/>
             <a:r>
-              <a:rPr lang="en-US" dirty="0"/>
+              <a:rPr lang="en-US" sz="1800" dirty="0"/>
               <a:t>Gene/species, Cancer</a:t>
             </a:r>
           </a:p>
@@ -4449,7 +4449,7 @@
           <a:p>
             <a:pPr lvl="2"/>
             <a:r>
-              <a:rPr lang="en-US" dirty="0"/>
+              <a:rPr lang="en-US" sz="1800" dirty="0"/>
               <a:t>Pipeline development, Rare disease </a:t>
             </a:r>
           </a:p>
@@ -4577,7 +4577,7 @@
             <a:pPr lvl="1"/>
             <a:r>
               <a:rPr lang="en-US" dirty="0"/>
-              <a:t>PhD student, Postdoc, Faculty, Staff</a:t>
+              <a:t>PhD student, Postdoc, Staff</a:t>
             </a:r>
           </a:p>
           <a:p>
@@ -4908,7 +4908,7 @@
             <p:ph idx="1"/>
             <p:extLst>
               <p:ext uri="{D42A27DB-BD31-4B8C-83A1-F6EECF244321}">
-                <p14:modId xmlns:p14="http://schemas.microsoft.com/office/powerpoint/2010/main" val="3600768959"/>
+                <p14:modId xmlns:p14="http://schemas.microsoft.com/office/powerpoint/2010/main" val="3571569903"/>
               </p:ext>
             </p:extLst>
           </p:nvPr>
@@ -5117,7 +5117,7 @@
                           <a:effectLst/>
                           <a:latin typeface="Helvetica Neue" panose="02000503000000020004" pitchFamily="2" charset="0"/>
                         </a:rPr>
-                        <a:t>09:30 - 10:20</a:t>
+                        <a:t>09:30 - 10:15</a:t>
                       </a:r>
                       <a:endParaRPr lang="en-SA" dirty="0">
                         <a:effectLst/>
@@ -5220,7 +5220,7 @@
                           <a:effectLst/>
                           <a:latin typeface="Helvetica Neue" panose="02000503000000020004" pitchFamily="2" charset="0"/>
                         </a:rPr>
-                        <a:t>10:20 - 10:30</a:t>
+                        <a:t>10:15 - 10:30</a:t>
                       </a:r>
                       <a:endParaRPr lang="en-SA" dirty="0">
                         <a:effectLst/>
@@ -5639,16 +5639,6 @@
                         <a:buNone/>
                       </a:pPr>
                       <a:r>
-                        <a:rPr lang="en-US" dirty="0" err="1">
-                          <a:solidFill>
-                            <a:srgbClr val="000000"/>
-                          </a:solidFill>
-                          <a:effectLst/>
-                          <a:latin typeface="Helvetica Neue" panose="02000503000000020004" pitchFamily="2" charset="0"/>
-                        </a:rPr>
-                        <a:t>HuggingFace</a:t>
-                      </a:r>
-                      <a:r>
                         <a:rPr lang="en-US" dirty="0">
                           <a:solidFill>
                             <a:srgbClr val="000000"/>
@@ -5656,7 +5646,7 @@
                           <a:effectLst/>
                           <a:latin typeface="Helvetica Neue" panose="02000503000000020004" pitchFamily="2" charset="0"/>
                         </a:rPr>
-                        <a:t> Ecosystem</a:t>
+                        <a:t>Hugging Face Ecosystem</a:t>
                       </a:r>
                       <a:endParaRPr lang="en-US" dirty="0">
                         <a:effectLst/>
@@ -7153,7 +7143,7 @@
           <a:p>
             <a:r>
               <a:rPr lang="en-US" dirty="0"/>
-              <a:t>Post-workshop feedback</a:t>
+              <a:t>Post-Workshop Feedback</a:t>
             </a:r>
             <a:endParaRPr lang="en-SA" dirty="0"/>
           </a:p>
@@ -8164,6 +8154,15 @@
 </file>
 
 <file path=customXml/item1.xml><?xml version="1.0" encoding="utf-8"?>
+<?mso-contentType ?>
+<FormTemplates xmlns="http://schemas.microsoft.com/sharepoint/v3/contenttype/forms">
+  <Display>DocumentLibraryForm</Display>
+  <Edit>DocumentLibraryForm</Edit>
+  <New>DocumentLibraryForm</New>
+</FormTemplates>
+</file>
+
+<file path=customXml/item2.xml><?xml version="1.0" encoding="utf-8"?>
 <p:properties xmlns:p="http://schemas.microsoft.com/office/2006/metadata/properties" xmlns:xsi="http://www.w3.org/2001/XMLSchema-instance" xmlns:pc="http://schemas.microsoft.com/office/infopath/2007/PartnerControls">
   <documentManagement>
     <_ip_UnifiedCompliancePolicyUIAction xmlns="http://schemas.microsoft.com/sharepoint/v3" xsi:nil="true"/>
@@ -8181,15 +8180,6 @@
     <MediaServiceKeyPoints xmlns="71af3243-3dd4-4a8d-8c0d-dd76da1f02a5" xsi:nil="true"/>
   </documentManagement>
 </p:properties>
-</file>
-
-<file path=customXml/item2.xml><?xml version="1.0" encoding="utf-8"?>
-<?mso-contentType ?>
-<FormTemplates xmlns="http://schemas.microsoft.com/sharepoint/v3/contenttype/forms">
-  <Display>DocumentLibraryForm</Display>
-  <Edit>DocumentLibraryForm</Edit>
-  <New>DocumentLibraryForm</New>
-</FormTemplates>
 </file>
 
 <file path=customXml/item3.xml><?xml version="1.0" encoding="utf-8"?>
@@ -8499,6 +8489,14 @@
 </file>
 
 <file path=customXml/itemProps1.xml><?xml version="1.0" encoding="utf-8"?>
+<ds:datastoreItem xmlns:ds="http://schemas.openxmlformats.org/officeDocument/2006/customXml" ds:itemID="{78F2847D-96C7-4634-93AB-D232DDB6E5EB}">
+  <ds:schemaRefs>
+    <ds:schemaRef ds:uri="http://schemas.microsoft.com/sharepoint/v3/contenttype/forms"/>
+  </ds:schemaRefs>
+</ds:datastoreItem>
+</file>
+
+<file path=customXml/itemProps2.xml><?xml version="1.0" encoding="utf-8"?>
 <ds:datastoreItem xmlns:ds="http://schemas.openxmlformats.org/officeDocument/2006/customXml" ds:itemID="{4D18307F-863E-465D-9426-B14DA0CBD25E}">
   <ds:schemaRefs>
     <ds:schemaRef ds:uri="http://schemas.microsoft.com/sharepoint/v3"/>
@@ -8513,14 +8511,6 @@
     <ds:schemaRef ds:uri="http://schemas.openxmlformats.org/package/2006/metadata/core-properties"/>
     <ds:schemaRef ds:uri="71af3243-3dd4-4a8d-8c0d-dd76da1f02a5"/>
     <ds:schemaRef ds:uri="http://purl.org/dc/dcmitype/"/>
-  </ds:schemaRefs>
-</ds:datastoreItem>
-</file>
-
-<file path=customXml/itemProps2.xml><?xml version="1.0" encoding="utf-8"?>
-<ds:datastoreItem xmlns:ds="http://schemas.openxmlformats.org/officeDocument/2006/customXml" ds:itemID="{78F2847D-96C7-4634-93AB-D232DDB6E5EB}">
-  <ds:schemaRefs>
-    <ds:schemaRef ds:uri="http://schemas.microsoft.com/sharepoint/v3/contenttype/forms"/>
   </ds:schemaRefs>
 </ds:datastoreItem>
 </file>

</xml_diff>